<commit_message>
Translate deck to English (full 24 slides)
All slide copy translated from French to English, preserving structure,
ranking, Santander deep-dive, and the Figma discovery script.

Notable English idiom adjustments:
- 'Pourquoi maintenant' → 'Why now'
- 'En train d'evaluer' → 'Being evaluated'
- 'Reste a faire' → 'Path of least resistance' / 'Shorter procurement'
- 'Phrase a dire' → 'What to say'
- Anti-blank phrases rewritten as natural English (not literal)
- Roman numerals and date formats kept consistent (D0-D30 vs J0-J30)

File name unchanged (Cursor_Enterprise_Disco_Challenge.pptx) — same
artifact, English copy. Regenerates PDF + 24 PNG previews.

Co-authored-by: heliemonnoyeur-source <heliemonnoyeur-source@users.noreply.github.com>
</commit_message>
<xml_diff>
--- a/decks/Cursor_Enterprise_Disco_Challenge.pptx
+++ b/decks/Cursor_Enterprise_Disco_Challenge.pptx
@@ -3426,7 +3426,7 @@
                 </a:solidFill>
                 <a:latin typeface="Inter"/>
               </a:rPr>
-              <a:t>~70 % des Fortune 1000 l'utilisent déjà.</a:t>
+              <a:t>~70% of the Fortune 1000 already use it.</a:t>
             </a:r>
           </a:p>
         </p:txBody>
@@ -3498,13 +3498,13 @@
               </a:lnSpc>
             </a:pPr>
             <a:r>
-              <a:rPr sz="1400" b="0" i="0">
+              <a:rPr sz="1300" b="0" i="0">
                 <a:solidFill>
                   <a:srgbClr val="F5F5F5"/>
                 </a:solidFill>
                 <a:latin typeface="Inter"/>
               </a:rPr>
-              <a:t>P1 · Greenfield F100  (20–25')</a:t>
+              <a:t>P1 · Greenfield (Spain &amp; Italy)  (20–25')</a:t>
             </a:r>
           </a:p>
           <a:p>
@@ -3514,7 +3514,7 @@
               </a:lnSpc>
             </a:pPr>
             <a:r>
-              <a:rPr sz="1400" b="0" i="0">
+              <a:rPr sz="1300" b="0" i="0">
                 <a:solidFill>
                   <a:srgbClr val="F5F5F5"/>
                 </a:solidFill>
@@ -3530,7 +3530,7 @@
               </a:lnSpc>
             </a:pPr>
             <a:r>
-              <a:rPr sz="1400" b="0" i="0">
+              <a:rPr sz="1300" b="0" i="0">
                 <a:solidFill>
                   <a:srgbClr val="F5F5F5"/>
                 </a:solidFill>
@@ -4046,7 +4046,7 @@
                 </a:solidFill>
                 <a:latin typeface="Inter"/>
               </a:rPr>
-              <a:t>VP Eng · ~650 ingénieurs · 85 % VS Code · Copilot déployé ·</a:t>
+              <a:t>VP Eng · ~650 engineers · 85% VS Code · Copilot deployed ·</a:t>
             </a:r>
           </a:p>
           <a:p>
@@ -4062,7 +4062,7 @@
                 </a:solidFill>
                 <a:latin typeface="Inter"/>
               </a:rPr>
-              <a:t>Claude Code en évaluation · 31 Cursor Pro shadow (Privacy Mode mixte).</a:t>
+              <a:t>Claude Code being evaluated · 31 Cursor Pro shadow users (mixed Privacy Mode).</a:t>
             </a:r>
           </a:p>
         </p:txBody>
@@ -4402,7 +4402,7 @@
                 </a:solidFill>
                 <a:latin typeface="Inter"/>
               </a:rPr>
-              <a:t>CE QU'ON SAIT AVANT D'ENTRER</a:t>
+              <a:t>WHAT WE KNOW BEFORE WE WALK IN</a:t>
             </a:r>
           </a:p>
         </p:txBody>
@@ -4441,7 +4441,7 @@
                 </a:solidFill>
                 <a:latin typeface="Inter"/>
               </a:rPr>
-              <a:t>Le brief, en 6 faits.</a:t>
+              <a:t>The brief, in 6 facts.</a:t>
             </a:r>
           </a:p>
         </p:txBody>
@@ -4480,7 +4480,7 @@
                 </a:solidFill>
                 <a:latin typeface="Inter"/>
               </a:rPr>
-              <a:t>Chaque fait est un levier discovery. On les exploite — pas on les répète.</a:t>
+              <a:t>Every fact is a discovery lever. We leverage them — not repeat them.</a:t>
             </a:r>
           </a:p>
         </p:txBody>
@@ -4597,7 +4597,7 @@
                 </a:solidFill>
                 <a:latin typeface="Inter"/>
               </a:rPr>
-              <a:t>→ Buyer économique principal. KPI : vélocité, talent.</a:t>
+              <a:t>→ Primary economic buyer. KPIs: velocity, talent.</a:t>
             </a:r>
           </a:p>
         </p:txBody>
@@ -4680,7 +4680,7 @@
                 </a:solidFill>
                 <a:latin typeface="Inter"/>
               </a:rPr>
-              <a:t>~85 % sur VS Code</a:t>
+              <a:t>~85% on VS Code</a:t>
             </a:r>
           </a:p>
         </p:txBody>
@@ -4719,7 +4719,7 @@
                 </a:solidFill>
                 <a:latin typeface="Inter"/>
               </a:rPr>
-              <a:t>Standard interne dominant.</a:t>
+              <a:t>Dominant internal standard.</a:t>
             </a:r>
           </a:p>
         </p:txBody>
@@ -4880,7 +4880,7 @@
                 </a:solidFill>
                 <a:latin typeface="Inter"/>
               </a:rPr>
-              <a:t>Déployé sur toute l'équipe.</a:t>
+              <a:t>Deployed across the entire team.</a:t>
             </a:r>
           </a:p>
         </p:txBody>
@@ -4919,7 +4919,7 @@
                 </a:solidFill>
                 <a:latin typeface="Inter"/>
               </a:rPr>
-              <a:t>→ Baseline connu. « Why change » = quality gap, pas absence d'outil.</a:t>
+              <a:t>→ Known baseline. 'Why change' = quality gap, not absence of tool.</a:t>
             </a:r>
           </a:p>
         </p:txBody>
@@ -5041,7 +5041,7 @@
                 </a:solidFill>
                 <a:latin typeface="Inter"/>
               </a:rPr>
-              <a:t>En évaluation active en ce moment.</a:t>
+              <a:t>Actively under evaluation right now.</a:t>
             </a:r>
           </a:p>
         </p:txBody>
@@ -5080,7 +5080,7 @@
                 </a:solidFill>
                 <a:latin typeface="Inter"/>
               </a:rPr>
-              <a:t>→ THE compétiteur. Why now est déjà établi de leur côté.</a:t>
+              <a:t>→ THE competitor. 'Why now' is already established on their side.</a:t>
             </a:r>
           </a:p>
         </p:txBody>
@@ -5202,7 +5202,7 @@
                 </a:solidFill>
                 <a:latin typeface="Inter"/>
               </a:rPr>
-              <a:t>Shadow usage interne, Privacy Mode mixte.</a:t>
+              <a:t>Shadow internal usage, mixed Privacy Mode.</a:t>
             </a:r>
           </a:p>
         </p:txBody>
@@ -5241,7 +5241,7 @@
                 </a:solidFill>
                 <a:latin typeface="Inter"/>
               </a:rPr>
-              <a:t>→ Or pur. Champion silencieux + risque sécu = leur problème, notre wedge.</a:t>
+              <a:t>→ Gold. Silent champion + sec risk = their problem, our wedge.</a:t>
             </a:r>
           </a:p>
         </p:txBody>
@@ -5402,7 +5402,7 @@
                 </a:solidFill>
                 <a:latin typeface="Inter"/>
               </a:rPr>
-              <a:t>→ 2/3 sécu. La conversation est sécurité-first, pas velocity-first.</a:t>
+              <a:t>→ 2 of 3 are security. This is a security-first conversation.</a:t>
             </a:r>
           </a:p>
         </p:txBody>
@@ -5747,7 +5747,7 @@
                 </a:solidFill>
                 <a:latin typeface="Inter"/>
               </a:rPr>
-              <a:t>STRUCTURE DU CALL</a:t>
+              <a:t>CALL STRUCTURE</a:t>
             </a:r>
           </a:p>
         </p:txBody>
@@ -5786,7 +5786,7 @@
                 </a:solidFill>
                 <a:latin typeface="Inter"/>
               </a:rPr>
-              <a:t>20–25 minutes, timeboxé.</a:t>
+              <a:t>20–25 minutes, timeboxed.</a:t>
             </a:r>
           </a:p>
         </p:txBody>
@@ -5825,7 +5825,7 @@
                 </a:solidFill>
                 <a:latin typeface="Inter"/>
               </a:rPr>
-              <a:t>Marcel parle d'abord. Sécu entre minute 5. Goal = follow-up précis, pas pilote.</a:t>
+              <a:t>Marcel speaks first. Security joins minute 5. Goal = specific follow-up, not pilot close.</a:t>
             </a:r>
           </a:p>
         </p:txBody>
@@ -5903,7 +5903,7 @@
                 </a:solidFill>
                 <a:latin typeface="Inter"/>
               </a:rPr>
-              <a:t>Cadrage</a:t>
+              <a:t>Framing</a:t>
             </a:r>
           </a:p>
         </p:txBody>
@@ -5942,7 +5942,7 @@
                 </a:solidFill>
                 <a:latin typeface="Inter"/>
               </a:rPr>
-              <a:t>Agenda · permission · ancrage sur les 31 Pro users.</a:t>
+              <a:t>Agenda · permission · anchor on the 31 Pro users.</a:t>
             </a:r>
           </a:p>
         </p:txBody>
@@ -6103,7 +6103,7 @@
                 </a:solidFill>
                 <a:latin typeface="Inter"/>
               </a:rPr>
-              <a:t>Marcel d'abord, Sécurité à partir de 5:00.</a:t>
+              <a:t>Marcel first, Security from minute 5.</a:t>
             </a:r>
           </a:p>
         </p:txBody>
@@ -6225,7 +6225,7 @@
                 </a:solidFill>
                 <a:latin typeface="Inter"/>
               </a:rPr>
-              <a:t>Thèse + 1 proof point</a:t>
+              <a:t>Thesis + 1 proof point</a:t>
             </a:r>
           </a:p>
         </p:txBody>
@@ -6264,7 +6264,7 @@
                 </a:solidFill>
                 <a:latin typeface="Inter"/>
               </a:rPr>
-              <a:t>Why now (urgence eux) · why Cursor (vs Claude Code).</a:t>
+              <a:t>Why now (their urgency) · why Cursor (vs Claude Code).</a:t>
             </a:r>
           </a:p>
         </p:txBody>
@@ -6386,7 +6386,7 @@
                 </a:solidFill>
                 <a:latin typeface="Inter"/>
               </a:rPr>
-              <a:t>Sécurité</a:t>
+              <a:t>Security</a:t>
             </a:r>
           </a:p>
         </p:txBody>
@@ -6425,7 +6425,7 @@
                 </a:solidFill>
                 <a:latin typeface="Inter"/>
               </a:rPr>
-              <a:t>Privacy Mode 3 bullets + SOC 2. J'ouvre, pas eux.</a:t>
+              <a:t>Privacy Mode 3 bullets + SOC 2. I open it, not them.</a:t>
             </a:r>
           </a:p>
         </p:txBody>
@@ -6547,7 +6547,7 @@
                 </a:solidFill>
                 <a:latin typeface="Inter"/>
               </a:rPr>
-              <a:t>Next step précis</a:t>
+              <a:t>Specific next step</a:t>
             </a:r>
           </a:p>
         </p:txBody>
@@ -6586,7 +6586,7 @@
                 </a:solidFill>
                 <a:latin typeface="Inter"/>
               </a:rPr>
-              <a:t>Follow-up nommé : qui, quand, pour quoi faire.</a:t>
+              <a:t>Named follow-up: who, when, what for.</a:t>
             </a:r>
           </a:p>
         </p:txBody>
@@ -6931,7 +6931,7 @@
                 </a:solidFill>
                 <a:latin typeface="Inter"/>
               </a:rPr>
-              <a:t>LES 90 PREMIÈRES SECONDES</a:t>
+              <a:t>THE FIRST 90 SECONDS</a:t>
             </a:r>
           </a:p>
         </p:txBody>
@@ -6970,7 +6970,7 @@
                 </a:solidFill>
                 <a:latin typeface="Inter"/>
               </a:rPr>
-              <a:t>Script d'ouverture.</a:t>
+              <a:t>Opening script.</a:t>
             </a:r>
           </a:p>
         </p:txBody>
@@ -7009,7 +7009,7 @@
                 </a:solidFill>
                 <a:latin typeface="Inter"/>
               </a:rPr>
-              <a:t>Préparation visible (nom, faits) · pas de pitch · pré-engagement sur l'agenda.</a:t>
+              <a:t>Visible preparation (name, facts) · no pitch · pre-engagement on the agenda.</a:t>
             </a:r>
           </a:p>
         </p:txBody>
@@ -7175,7 +7175,7 @@
                 </a:solidFill>
                 <a:latin typeface="Inter"/>
               </a:rPr>
-              <a:t>Marcel, merci pour ces 20 minutes — et merci à [Security Eng Lead] et [Sec team member] de vous être joints, c'est exactement la configuration la plus utile pour cette conversation. Avant de commencer : j'ai noté que 31 de vos ingénieurs sont déjà sur Cursor Pro en mode mixte. Plutôt que de pitcher, je préfère partir de cette réalité — comprendre ce que vous en voyez en interne, ce qui pousse l'évaluation Claude Code en parallèle, et où vous voulez emmener tout ça à 6 mois. Je vais passer le plus clair du temps à poser des questions. Goal côté Cursor : un follow-up précis et utile, pas un pitch. Ça vous va comme cadrage ?</a:t>
+              <a:t>Marcel, thanks for the 20 minutes — and thanks to [Security Eng Lead] and [Sec team member] for joining, this is exactly the right room for this conversation. Before we start: I noticed 31 of your engineers are already on Cursor Pro in mixed Privacy Mode. Rather than pitching, I'd rather start from that reality — understand what you're seeing internally, what's pulling the Claude Code evaluation in parallel, and where you want all of this to be in 6 months. I'm going to spend most of the time asking questions. My goal on Cursor's side: a specific, useful follow-up, not a pitch. Does that framing work for you?</a:t>
             </a:r>
           </a:p>
         </p:txBody>
@@ -7214,7 +7214,7 @@
                 </a:solidFill>
                 <a:latin typeface="Inter"/>
               </a:rPr>
-              <a:t>EFFETS — préparation visible (31 Pro, Claude Code) · self-aware (pas de pitch) · pré-engagement · sécu impliquée dès le mot 1</a:t>
+              <a:t>EFFECTS — visible preparation (31 Pro, Claude Code) · self-aware (no pitch) · pre-engagement · security involved from word 1</a:t>
             </a:r>
           </a:p>
         </p:txBody>
@@ -7554,7 +7554,7 @@
                 </a:solidFill>
                 <a:latin typeface="Inter"/>
               </a:rPr>
-              <a:t>Questions ancrées sur les faits.</a:t>
+              <a:t>Questions anchored on the facts.</a:t>
             </a:r>
           </a:p>
         </p:txBody>
@@ -7593,7 +7593,7 @@
                 </a:solidFill>
                 <a:latin typeface="Inter"/>
               </a:rPr>
-              <a:t>Chaque question pointe un fait connu. Pas de question générique.</a:t>
+              <a:t>Every question points at a known fact. No generic questions.</a:t>
             </a:r>
           </a:p>
         </p:txBody>
@@ -7671,7 +7671,7 @@
                 </a:solidFill>
                 <a:latin typeface="Inter"/>
               </a:rPr>
-              <a:t>Origine du shadow</a:t>
+              <a:t>Origin of shadow</a:t>
             </a:r>
           </a:p>
         </p:txBody>
@@ -7710,7 +7710,7 @@
                 </a:solidFill>
                 <a:latin typeface="Inter"/>
               </a:rPr>
-              <a:t>« 31 ingés sur Cursor Pro — comment c'est arrivé, et qu'est-ce qu'ils en disent quand vous leur demandez ? »</a:t>
+              <a:t>"31 engineers on Cursor Pro — how did that happen, and what do they say when you ask them?"</a:t>
             </a:r>
           </a:p>
         </p:txBody>
@@ -7749,7 +7749,7 @@
                 </a:solidFill>
                 <a:latin typeface="Inter"/>
               </a:rPr>
-              <a:t>→ Bottom-up signal. Si Marcel l'ignorait, c'est un trou de visibilité = wedge.</a:t>
+              <a:t>→ Bottom-up signal. If Marcel didn't know, that's a visibility gap = wedge.</a:t>
             </a:r>
           </a:p>
         </p:txBody>
@@ -7910,7 +7910,7 @@
                 </a:solidFill>
                 <a:latin typeface="Inter"/>
               </a:rPr>
-              <a:t>« Qu'est-ce qui vous a fait regarder Claude Code maintenant plutôt qu'il y a 6 mois, et qu'est-ce que vous attendez d'un éventuel switch ? »</a:t>
+              <a:t>"What made you look at Claude Code now rather than 6 months ago, and what would you expect from a switch?"</a:t>
             </a:r>
           </a:p>
         </p:txBody>
@@ -7949,7 +7949,7 @@
                 </a:solidFill>
                 <a:latin typeface="Inter"/>
               </a:rPr>
-              <a:t>→ Le « why now » est ici. On laisse Marcel le formuler à notre place.</a:t>
+              <a:t>→ 'Why now' lives here. We let Marcel articulate it for us.</a:t>
             </a:r>
           </a:p>
         </p:txBody>
@@ -8071,7 +8071,7 @@
                 </a:solidFill>
                 <a:latin typeface="Inter"/>
               </a:rPr>
-              <a:t>Gap Copilot</a:t>
+              <a:t>Copilot gap</a:t>
             </a:r>
           </a:p>
         </p:txBody>
@@ -8110,7 +8110,7 @@
                 </a:solidFill>
                 <a:latin typeface="Inter"/>
               </a:rPr>
-              <a:t>« Copilot est déployé wall-to-wall — quel est le travail qui devrait être assisté et ne l'est pas aujourd'hui ? »</a:t>
+              <a:t>"Copilot is deployed wall-to-wall — what work should be assisted but isn't today?"</a:t>
             </a:r>
           </a:p>
         </p:txBody>
@@ -8149,7 +8149,7 @@
                 </a:solidFill>
                 <a:latin typeface="Inter"/>
               </a:rPr>
-              <a:t>→ Refactos · large context · review. Là où Cursor a un edge tangible.</a:t>
+              <a:t>→ Refactors · large context · review. Where Cursor has a tangible edge.</a:t>
             </a:r>
           </a:p>
         </p:txBody>
@@ -8310,7 +8310,7 @@
                 </a:solidFill>
                 <a:latin typeface="Inter"/>
               </a:rPr>
-              <a:t>« Les seniors et les juniors utilisent Copilot pareil ? Y a-t-il un tier qui a discrètement décroché ? »</a:t>
+              <a:t>"Are senior and junior engineers using Copilot the same way? Is there a tier that's quietly disengaged?"</a:t>
             </a:r>
           </a:p>
         </p:txBody>
@@ -8349,7 +8349,7 @@
                 </a:solidFill>
                 <a:latin typeface="Inter"/>
               </a:rPr>
-              <a:t>→ Senior opt-out = plafond ROI ~5 %. Notre meilleure preuve de gap.</a:t>
+              <a:t>→ Senior opt-out = org ROI capped at ~5%. Our strongest gap proof.</a:t>
             </a:r>
           </a:p>
         </p:txBody>
@@ -8533,7 +8533,7 @@
                 </a:solidFill>
                 <a:latin typeface="Inter"/>
               </a:rPr>
-              <a:t>PART 2  ·  DISCO · SÉCURITÉ</a:t>
+              <a:t>PART 2  ·  DISCO · SECURITY</a:t>
             </a:r>
           </a:p>
         </p:txBody>
@@ -8694,7 +8694,7 @@
                 </a:solidFill>
                 <a:latin typeface="Inter"/>
               </a:rPr>
-              <a:t>EMBARQUER LA SÉCURITÉ (2/3 ATTENDEES)</a:t>
+              <a:t>BRING SECURITY IN (2 OF 3 ATTENDEES)</a:t>
             </a:r>
           </a:p>
         </p:txBody>
@@ -8733,7 +8733,7 @@
                 </a:solidFill>
                 <a:latin typeface="Inter"/>
               </a:rPr>
-              <a:t>Questions sécurité ancrées sur le shadow Cursor.</a:t>
+              <a:t>Security questions anchored on the shadow Cursor reality.</a:t>
             </a:r>
           </a:p>
         </p:txBody>
@@ -8772,7 +8772,7 @@
                 </a:solidFill>
                 <a:latin typeface="Inter"/>
               </a:rPr>
-              <a:t>Le sujet est déjà sur leur table — 31 Pro users en mode mixte. On le nomme.</a:t>
+              <a:t>The topic is already on their desk — 31 Pro users in mixed Privacy Mode. We name it.</a:t>
             </a:r>
           </a:p>
         </p:txBody>
@@ -8889,7 +8889,7 @@
                 </a:solidFill>
                 <a:latin typeface="Inter"/>
               </a:rPr>
-              <a:t>« Les 31 utilisateurs Pro avec Privacy Mode mixte — ça a déclenché un review interne, ou pas encore ? »</a:t>
+              <a:t>"The 31 Pro users in mixed Privacy Mode — has that triggered an internal review yet, or not?"</a:t>
             </a:r>
           </a:p>
         </p:txBody>
@@ -8928,7 +8928,7 @@
                 </a:solidFill>
                 <a:latin typeface="Inter"/>
               </a:rPr>
-              <a:t>→ Pose la réalité du risque actuel sans la dramatiser.</a:t>
+              <a:t>→ Surface the existing risk without dramatizing it.</a:t>
             </a:r>
           </a:p>
         </p:txBody>
@@ -9050,7 +9050,7 @@
                 </a:solidFill>
                 <a:latin typeface="Inter"/>
               </a:rPr>
-              <a:t>Critères de sanction</a:t>
+              <a:t>Sanction criteria</a:t>
             </a:r>
           </a:p>
         </p:txBody>
@@ -9089,7 +9089,7 @@
                 </a:solidFill>
                 <a:latin typeface="Inter"/>
               </a:rPr>
-              <a:t>« Qu'est-ce qu'un outil IA de code doit prouver pour être sanctionné chez Figma — au-delà de SOC 2 ? »</a:t>
+              <a:t>"What does an AI coding tool need to prove to be sanctioned at Figma — beyond SOC 2?"</a:t>
             </a:r>
           </a:p>
         </p:txBody>
@@ -9128,7 +9128,7 @@
                 </a:solidFill>
                 <a:latin typeface="Inter"/>
               </a:rPr>
-              <a:t>→ Audit logs ? Data residency ? BYO-key ? On note pour anticiper.</a:t>
+              <a:t>→ Audit logs? Data residency? BYO-key? We note it to anticipate.</a:t>
             </a:r>
           </a:p>
         </p:txBody>
@@ -9250,7 +9250,7 @@
                 </a:solidFill>
                 <a:latin typeface="Inter"/>
               </a:rPr>
-              <a:t>Posture Claude Code</a:t>
+              <a:t>Claude Code security posture</a:t>
             </a:r>
           </a:p>
         </p:txBody>
@@ -9289,7 +9289,7 @@
                 </a:solidFill>
                 <a:latin typeface="Inter"/>
               </a:rPr>
-              <a:t>« Comment l'évaluation Claude Code se passe côté sécurité — qu'est-ce que vous regardez en parallèle de la capacité produit ? »</a:t>
+              <a:t>"How is the Claude Code evaluation going on the security side — what are you looking at alongside product capability?"</a:t>
             </a:r>
           </a:p>
         </p:txBody>
@@ -9328,7 +9328,7 @@
                 </a:solidFill>
                 <a:latin typeface="Inter"/>
               </a:rPr>
-              <a:t>→ Donne le terrain de comparaison. Privacy Mode est un argument différenciateur.</a:t>
+              <a:t>→ Reveals the comparison terrain. Privacy Mode is a differentiated argument.</a:t>
             </a:r>
           </a:p>
         </p:txBody>
@@ -9673,7 +9673,7 @@
                 </a:solidFill>
                 <a:latin typeface="Inter"/>
               </a:rPr>
-              <a:t>TROIS ANGLES QUI MATCHENT LEUR RÉALITÉ</a:t>
+              <a:t>THREE ANGLES THAT MATCH THEIR REALITY</a:t>
             </a:r>
           </a:p>
         </p:txBody>
@@ -9712,7 +9712,7 @@
                 </a:solidFill>
                 <a:latin typeface="Inter"/>
               </a:rPr>
-              <a:t>Pourquoi Cursor — calibré pour ce dossier précis.</a:t>
+              <a:t>Why Cursor — calibrated for this specific account.</a:t>
             </a:r>
           </a:p>
         </p:txBody>
@@ -9751,7 +9751,7 @@
                 </a:solidFill>
                 <a:latin typeface="Inter"/>
               </a:rPr>
-              <a:t>On reprend les 4 différenciateurs officiels et on les zoom sur Figma.</a:t>
+              <a:t>We take the 4 official differentiators and zoom them onto Figma.</a:t>
             </a:r>
           </a:p>
         </p:txBody>
@@ -9956,7 +9956,7 @@
                 </a:solidFill>
                 <a:latin typeface="Inter"/>
               </a:rPr>
-              <a:t>85 % de l'équipe est déjà sur VS Code. Muscle memory, extensions, keymaps, settings transfèrent. Coût d'adoption ≈ 0.</a:t>
+              <a:t>85% of the team is already on VS Code. Muscle memory, extensions, keymaps, settings carry over. Adoption cost ≈ 0.</a:t>
             </a:r>
           </a:p>
         </p:txBody>
@@ -10161,7 +10161,7 @@
                 </a:solidFill>
                 <a:latin typeface="Inter"/>
               </a:rPr>
-              <a:t>Éditeur C++/WASM + infra Rust/TS = repo complexe. C'est exactement le terrain où Cursor surperforme — semantic search, indexing, retrieval.</a:t>
+              <a:t>C++/WASM editor + Rust/TS infra = complex repo. Exactly where Cursor outperforms — semantic search, indexing, retrieval.</a:t>
             </a:r>
           </a:p>
         </p:txBody>
@@ -10366,7 +10366,7 @@
                 </a:solidFill>
                 <a:latin typeface="Inter"/>
               </a:rPr>
-              <a:t>Claude Code = Anthropic-locked. Cursor donne accès au SOTA en continu — vous ne pariez pas la prochaine année sur un seul provider.</a:t>
+              <a:t>Claude Code = Anthropic-locked. Cursor keeps SOTA access flowing — you don't bet the next year on a single provider.</a:t>
             </a:r>
           </a:p>
         </p:txBody>
@@ -10571,7 +10571,7 @@
                 </a:solidFill>
                 <a:latin typeface="Inter"/>
               </a:rPr>
-              <a:t>Plan · write · review · debug · iterate dans un seul environnement. Pas un CLI à côté de l'IDE. Workflow integration &gt; intelligence brute.</a:t>
+              <a:t>Plan · write · review · debug · iterate in one environment. Not a CLI next to the IDE. Workflow integration &gt; raw intelligence.</a:t>
             </a:r>
           </a:p>
         </p:txBody>
@@ -10711,7 +10711,7 @@
                 </a:solidFill>
                 <a:latin typeface="Inter"/>
               </a:rPr>
-              <a:t>PART 2  ·  SÉCURITÉ · PRIVACY MODE</a:t>
+              <a:t>PART 2  ·  SECURITY · PRIVACY MODE</a:t>
             </a:r>
           </a:p>
         </p:txBody>
@@ -10872,7 +10872,7 @@
                 </a:solidFill>
                 <a:latin typeface="Inter"/>
               </a:rPr>
-              <a:t>MINUTE 13 — JE L'OUVRE MOI-MÊME</a:t>
+              <a:t>MINUTE 13 — I RAISE IT MYSELF</a:t>
             </a:r>
           </a:p>
         </p:txBody>
@@ -10911,7 +10911,7 @@
                 </a:solidFill>
                 <a:latin typeface="Inter"/>
               </a:rPr>
-              <a:t>Le sujet est déjà chez eux. On le tranche.</a:t>
+              <a:t>The topic is already with them. We resolve it.</a:t>
             </a:r>
           </a:p>
         </p:txBody>
@@ -10950,7 +10950,7 @@
                 </a:solidFill>
                 <a:latin typeface="Inter"/>
               </a:rPr>
-              <a:t>31 Pro users en Privacy Mode mixte = le risque est déjà réel. Voici comment Cursor le règle.</a:t>
+              <a:t>31 Pro users in mixed Privacy Mode = real existing risk. Here's how Cursor resolves it.</a:t>
             </a:r>
           </a:p>
         </p:txBody>
@@ -11028,7 +11028,7 @@
                 </a:solidFill>
                 <a:latin typeface="Inter"/>
               </a:rPr>
-              <a:t>Code non-stocké</a:t>
+              <a:t>Code not retained</a:t>
             </a:r>
           </a:p>
         </p:txBody>
@@ -11067,7 +11067,7 @@
                 </a:solidFill>
                 <a:latin typeface="Inter"/>
               </a:rPr>
-              <a:t>Customer code is not stored or retained — c'est contractuel, pas un toggle.</a:t>
+              <a:t>Customer code is not stored or retained — contractual, not a toggle.</a:t>
             </a:r>
           </a:p>
         </p:txBody>
@@ -11189,7 +11189,7 @@
                 </a:solidFill>
                 <a:latin typeface="Inter"/>
               </a:rPr>
-              <a:t>Pas d'entraînement</a:t>
+              <a:t>No training</a:t>
             </a:r>
           </a:p>
         </p:txBody>
@@ -11228,7 +11228,7 @@
                 </a:solidFill>
                 <a:latin typeface="Inter"/>
               </a:rPr>
-              <a:t>Code is not used to train models — ni les nôtres, ni ceux des providers tiers.</a:t>
+              <a:t>Code is not used to train models — neither ours, nor third-party providers'.</a:t>
             </a:r>
           </a:p>
         </p:txBody>
@@ -11350,7 +11350,7 @@
                 </a:solidFill>
                 <a:latin typeface="Inter"/>
               </a:rPr>
-              <a:t>Requêtes éphémères</a:t>
+              <a:t>Ephemeral requests</a:t>
             </a:r>
           </a:p>
         </p:txBody>
@@ -11389,7 +11389,7 @@
                 </a:solidFill>
                 <a:latin typeface="Inter"/>
               </a:rPr>
-              <a:t>Requests are isolated and ephemeral — pas de log persistant des prompts.</a:t>
+              <a:t>Requests are isolated and ephemeral — no persistent prompt logs.</a:t>
             </a:r>
           </a:p>
         </p:txBody>
@@ -11550,7 +11550,7 @@
                 </a:solidFill>
                 <a:latin typeface="Inter"/>
               </a:rPr>
-              <a:t>SOC 2 · contrôles admin · visibilité · SSO. Call security ↔ security sous 7 jours.</a:t>
+              <a:t>SOC 2 · admin controls · visibility · SSO. Security ↔ security call within 7 days.</a:t>
             </a:r>
           </a:p>
         </p:txBody>
@@ -11672,7 +11672,7 @@
                 </a:solidFill>
                 <a:latin typeface="Inter"/>
               </a:rPr>
-              <a:t>Conversion shadow → sanctionné</a:t>
+              <a:t>Shadow → sanctioned</a:t>
             </a:r>
           </a:p>
         </p:txBody>
@@ -11711,7 +11711,7 @@
                 </a:solidFill>
                 <a:latin typeface="Inter"/>
               </a:rPr>
-              <a:t>Les 31 Pro users actuels peuvent basculer en Privacy Mode mandaté en &lt; 1 jour.</a:t>
+              <a:t>The 31 current Pro users can switch to mandated Privacy Mode in &lt; 1 day.</a:t>
             </a:r>
           </a:p>
         </p:txBody>
@@ -12056,7 +12056,7 @@
                 </a:solidFill>
                 <a:latin typeface="Inter"/>
               </a:rPr>
-              <a:t>MINUTE 17 — LA SORTIE</a:t>
+              <a:t>MINUTE 17 — THE EXIT</a:t>
             </a:r>
           </a:p>
         </p:txBody>
@@ -12095,7 +12095,7 @@
                 </a:solidFill>
                 <a:latin typeface="Inter"/>
               </a:rPr>
-              <a:t>Goal de l'exercice : un follow-up précis.</a:t>
+              <a:t>The exercise goal: a specific follow-up.</a:t>
             </a:r>
           </a:p>
         </p:txBody>
@@ -12134,7 +12134,7 @@
                 </a:solidFill>
                 <a:latin typeface="Inter"/>
               </a:rPr>
-              <a:t>Pas un pilote. Pas un « on se rappelle ». Un meeting nommé, daté, avec un purpose.</a:t>
+              <a:t>Not a pilot. Not a 'let's reconnect.' A named meeting, dated, with a purpose.</a:t>
             </a:r>
           </a:p>
         </p:txBody>
@@ -12261,7 +12261,7 @@
                 </a:solidFill>
                 <a:latin typeface="Inter"/>
               </a:rPr>
-              <a:t>FOLLOW-UP PROPOSÉ</a:t>
+              <a:t>PROPOSED FOLLOW-UP</a:t>
             </a:r>
           </a:p>
         </p:txBody>
@@ -12294,13 +12294,13 @@
               </a:lnSpc>
             </a:pPr>
             <a:r>
-              <a:rPr sz="1800" b="1" i="0">
+              <a:rPr sz="1700" b="1" i="0">
                 <a:solidFill>
                   <a:srgbClr val="F5F5F5"/>
                 </a:solidFill>
                 <a:latin typeface="Inter"/>
               </a:rPr>
-              <a:t>60 min, sous 10 jours — Cursor SE + Cursor Security ↔ Figma DevEx + AppSec.</a:t>
+              <a:t>60 minutes, within 10 days — Cursor SE + Cursor Security ↔ Figma DevEx + AppSec.</a:t>
             </a:r>
           </a:p>
         </p:txBody>
@@ -12339,7 +12339,7 @@
                 </a:solidFill>
                 <a:latin typeface="Inter"/>
               </a:rPr>
-              <a:t>Purpose : (1) scoping technique d'un POC 20–30 ingés sur un repo nommé, métriques pré-définies,</a:t>
+              <a:t>Purpose: (1) technical scoping of a 20–30-engineer POC on a named repo, pre-defined metrics,</a:t>
             </a:r>
           </a:p>
           <a:p>
@@ -12355,7 +12355,7 @@
                 </a:solidFill>
                 <a:latin typeface="Inter"/>
               </a:rPr>
-              <a:t>Privacy Mode mandaté ; (2) review sécu parallèle (SIG, pentest, archi, DPA envoyés J-7).</a:t>
+              <a:t>Privacy Mode mandated; (2) parallel security review (SIG, pentest, architecture, DPA sent D-7).</a:t>
             </a:r>
           </a:p>
         </p:txBody>
@@ -12394,7 +12394,7 @@
                 </a:solidFill>
                 <a:latin typeface="Inter"/>
               </a:rPr>
-              <a:t>PHRASE À DIRE</a:t>
+              <a:t>WHAT TO SAY</a:t>
             </a:r>
           </a:p>
         </p:txBody>
@@ -12433,7 +12433,7 @@
                 </a:solidFill>
                 <a:latin typeface="Inter"/>
               </a:rPr>
-              <a:t>« Marcel, ça vaut le coup qu'on bloque 60 min sous 10 jours, vous + sécu + nos équivalents ? Je vous envoie le draft d'agenda dans la journée. »</a:t>
+              <a:t>"Marcel, is it worth blocking 60 minutes within 10 days — you + security + our counterparts? I'll send you a draft agenda today."</a:t>
             </a:r>
           </a:p>
         </p:txBody>
@@ -12755,7 +12755,7 @@
                 </a:solidFill>
                 <a:latin typeface="Inter"/>
               </a:rPr>
-              <a:t>2–3 min silencieuses pour rassembler. Puis : top insights · deal hypothesis ·</a:t>
+              <a:t>2–3 silent minutes to gather. Then: top insights · deal hypothesis ·</a:t>
             </a:r>
           </a:p>
           <a:p>
@@ -12771,7 +12771,7 @@
                 </a:solidFill>
                 <a:latin typeface="Inter"/>
               </a:rPr>
-              <a:t>questions stratégiques · risks · self-assessment.</a:t>
+              <a:t>strategic questions · risks · self-assessment.</a:t>
             </a:r>
           </a:p>
         </p:txBody>
@@ -13111,7 +13111,7 @@
                 </a:solidFill>
                 <a:latin typeface="Inter"/>
               </a:rPr>
-              <a:t>60 MINUTES, TROIS EXERCICES CONNECTÉS</a:t>
+              <a:t>60 MINUTES, THREE CONNECTED EXERCISES</a:t>
             </a:r>
           </a:p>
         </p:txBody>
@@ -13150,7 +13150,7 @@
                 </a:solidFill>
                 <a:latin typeface="Inter"/>
               </a:rPr>
-              <a:t>Comment le temps va passer.</a:t>
+              <a:t>How the time will be spent.</a:t>
             </a:r>
           </a:p>
         </p:txBody>
@@ -13189,7 +13189,7 @@
                 </a:solidFill>
                 <a:latin typeface="Inter"/>
               </a:rPr>
-              <a:t>Account-development mindset informe la discovery. Une histoire, trois preuves.</a:t>
+              <a:t>Account-development mindset informs discovery. One story, three proofs.</a:t>
             </a:r>
           </a:p>
         </p:txBody>
@@ -13394,7 +13394,7 @@
                 </a:solidFill>
                 <a:latin typeface="Inter"/>
               </a:rPr>
-              <a:t>Greenfield Pipeline (F100)</a:t>
+              <a:t>Greenfield Pipeline (Spain &amp; Italy)</a:t>
             </a:r>
           </a:p>
         </p:txBody>
@@ -14222,7 +14222,7 @@
                 </a:solidFill>
                 <a:latin typeface="Inter"/>
               </a:rPr>
-              <a:t>À REMPLIR PENDANT LES 2 MIN SILENCIEUSES</a:t>
+              <a:t>TO FILL IN DURING THE 2 SILENT MINUTES</a:t>
             </a:r>
           </a:p>
         </p:txBody>
@@ -14261,7 +14261,7 @@
                 </a:solidFill>
                 <a:latin typeface="Inter"/>
               </a:rPr>
-              <a:t>Top 3–5 insights + hypothèse de deal.</a:t>
+              <a:t>Top 3–5 insights + deal hypothesis.</a:t>
             </a:r>
           </a:p>
         </p:txBody>
@@ -14300,7 +14300,7 @@
                 </a:solidFill>
                 <a:latin typeface="Inter"/>
               </a:rPr>
-              <a:t>Format : un insight = un fait observé en disco + ce qu'il déclenche.</a:t>
+              <a:t>Format: one insight = one observed fact from discovery + what it triggers.</a:t>
             </a:r>
           </a:p>
         </p:txBody>
@@ -14427,7 +14427,7 @@
                 </a:solidFill>
                 <a:latin typeface="Inter"/>
               </a:rPr>
-              <a:t>TOP INSIGHTS (à formuler en live)</a:t>
+              <a:t>TOP INSIGHTS (formulate live)</a:t>
             </a:r>
           </a:p>
         </p:txBody>
@@ -14466,7 +14466,7 @@
                 </a:solidFill>
                 <a:latin typeface="Inter"/>
               </a:rPr>
-              <a:t>1. Marcel sait pour les 31 ? → si oui, champion potentiel ; si non, trou de visibilité.</a:t>
+              <a:t>1. Does Marcel know about the 31? → if yes, potential champion; if no, visibility gap.</a:t>
             </a:r>
           </a:p>
         </p:txBody>
@@ -14505,7 +14505,7 @@
                 </a:solidFill>
                 <a:latin typeface="Inter"/>
               </a:rPr>
-              <a:t>2. Claude Code = vrai eval ou veille ? → urgence réelle ou parking.</a:t>
+              <a:t>2. Claude Code = real eval or scouting? → real urgency or parked.</a:t>
             </a:r>
           </a:p>
         </p:txBody>
@@ -14544,7 +14544,7 @@
                 </a:solidFill>
                 <a:latin typeface="Inter"/>
               </a:rPr>
-              <a:t>3. Senior IC opt-out sur Copilot ? → preuve de gap quality, pas absence d'outil.</a:t>
+              <a:t>3. Senior IC opt-out on Copilot? → proof of quality gap, not tool absence.</a:t>
             </a:r>
           </a:p>
         </p:txBody>
@@ -14583,7 +14583,7 @@
                 </a:solidFill>
                 <a:latin typeface="Inter"/>
               </a:rPr>
-              <a:t>4. Posture sécu : bloquant ou facilitant ? → vitesse de deal.</a:t>
+              <a:t>4. Security posture: blocking or facilitating? → deal velocity.</a:t>
             </a:r>
           </a:p>
         </p:txBody>
@@ -14622,7 +14622,7 @@
                 </a:solidFill>
                 <a:latin typeface="Inter"/>
               </a:rPr>
-              <a:t>5. Budget pré-alloué ? → délai de signature 3 mois vs 9 mois.</a:t>
+              <a:t>5. Pre-allocated budget? → 3-month vs 9-month signature delay.</a:t>
             </a:r>
           </a:p>
         </p:txBody>
@@ -14788,7 +14788,7 @@
                 </a:solidFill>
                 <a:latin typeface="Inter"/>
               </a:rPr>
-              <a:t>Setup typique :</a:t>
+              <a:t>Typical setup:</a:t>
             </a:r>
           </a:p>
           <a:p>
@@ -14804,7 +14804,7 @@
                 </a:solidFill>
                 <a:latin typeface="Inter"/>
               </a:rPr>
-              <a:t>• Urgence moyenne (Claude Code</a:t>
+              <a:t>• Medium urgency (Claude Code</a:t>
             </a:r>
           </a:p>
           <a:p>
@@ -14820,7 +14820,7 @@
                 </a:solidFill>
                 <a:latin typeface="Inter"/>
               </a:rPr>
-              <a:t>   est en eval, pas en décision)</a:t>
+              <a:t>   is in eval, not decision)</a:t>
             </a:r>
           </a:p>
           <a:p>
@@ -14836,7 +14836,7 @@
                 </a:solidFill>
                 <a:latin typeface="Inter"/>
               </a:rPr>
-              <a:t>• Champion à confirmer (Marcel ?</a:t>
+              <a:t>• Champion TBD (Marcel? or a</a:t>
             </a:r>
           </a:p>
           <a:p>
@@ -14852,7 +14852,7 @@
                 </a:solidFill>
                 <a:latin typeface="Inter"/>
               </a:rPr>
-              <a:t>   ou un staff IC sur les 31 Pro ?)</a:t>
+              <a:t>   staff IC among the 31 Pro?)</a:t>
             </a:r>
           </a:p>
           <a:p>
@@ -14868,7 +14868,7 @@
                 </a:solidFill>
                 <a:latin typeface="Inter"/>
               </a:rPr>
-              <a:t>• Sécu = vraie variable</a:t>
+              <a:t>• Security = real variable</a:t>
             </a:r>
           </a:p>
           <a:p>
@@ -14884,7 +14884,7 @@
                 </a:solidFill>
                 <a:latin typeface="Inter"/>
               </a:rPr>
-              <a:t>   (deal-maker ou deal-killer)</a:t>
+              <a:t>   (deal-maker or deal-killer)</a:t>
             </a:r>
           </a:p>
           <a:p>
@@ -14900,7 +14900,7 @@
                 </a:solidFill>
                 <a:latin typeface="Inter"/>
               </a:rPr>
-              <a:t>• Deal réaliste : POC à 60 j,</a:t>
+              <a:t>• Realistic deal: 60-day POC,</a:t>
             </a:r>
           </a:p>
           <a:p>
@@ -14916,7 +14916,7 @@
                 </a:solidFill>
                 <a:latin typeface="Inter"/>
               </a:rPr>
-              <a:t>   500–650 seats à 6–9 mois.</a:t>
+              <a:t>   500–650 seats at 6–9 months.</a:t>
             </a:r>
           </a:p>
         </p:txBody>
@@ -15056,7 +15056,7 @@
                 </a:solidFill>
                 <a:latin typeface="Inter"/>
               </a:rPr>
-              <a:t>PART 3  ·  DEBRIEF · QUESTIONS STRATÉGIQUES</a:t>
+              <a:t>PART 3  ·  DEBRIEF · STRATEGIC QUESTIONS</a:t>
             </a:r>
           </a:p>
         </p:txBody>
@@ -15217,7 +15217,7 @@
                 </a:solidFill>
                 <a:latin typeface="Inter"/>
               </a:rPr>
-              <a:t>LES 4 QUESTIONS DU PROMPT</a:t>
+              <a:t>THE 4 QUESTIONS FROM THE PROMPT</a:t>
             </a:r>
           </a:p>
         </p:txBody>
@@ -15256,7 +15256,7 @@
                 </a:solidFill>
                 <a:latin typeface="Inter"/>
               </a:rPr>
-              <a:t>Réponses préparées — à reformuler à chaud.</a:t>
+              <a:t>Pre-prepared answers — to reformulate live.</a:t>
             </a:r>
           </a:p>
         </p:txBody>
@@ -15295,7 +15295,7 @@
                 </a:solidFill>
                 <a:latin typeface="Inter"/>
               </a:rPr>
-              <a:t>Ne pas réciter. Reformuler avec ce qu'on aura entendu en disco.</a:t>
+              <a:t>Don't recite. Reformulate with what you heard in discovery.</a:t>
             </a:r>
           </a:p>
         </p:txBody>
@@ -15373,7 +15373,7 @@
                 </a:solidFill>
                 <a:latin typeface="Inter"/>
               </a:rPr>
-              <a:t>Pourquoi Figma a besoin d'une solution IA coding — Cursor ou pas ?</a:t>
+              <a:t>Why does Figma need an AI coding solution — Cursor or not?</a:t>
             </a:r>
           </a:p>
         </p:txBody>
@@ -15412,7 +15412,7 @@
                 </a:solidFill>
                 <a:latin typeface="Inter"/>
               </a:rPr>
-              <a:t>650 ingés sur du C++/WASM + Rust + TS = travail à haute complexité. Sans levier IA structuré, le talent senior va chercher la productivité ailleurs (interne ou externe).</a:t>
+              <a:t>650 engineers on C++/WASM + Rust + TS = high-complexity work. Without a structured AI lever, senior talent looks for productivity elsewhere (internal or external).</a:t>
             </a:r>
           </a:p>
         </p:txBody>
@@ -15534,7 +15534,7 @@
                 </a:solidFill>
                 <a:latin typeface="Inter"/>
               </a:rPr>
-              <a:t>Que se passe-t-il s'ils ne font rien pendant 3–6 mois ?</a:t>
+              <a:t>What happens if they do nothing for 3–6 months?</a:t>
             </a:r>
           </a:p>
         </p:txBody>
@@ -15573,7 +15573,7 @@
                 </a:solidFill>
                 <a:latin typeface="Inter"/>
               </a:rPr>
-              <a:t>Shadow Cursor monte de 31 à 100+. Claude Code peut-être déployé sans gouvernance. Le coût n'est pas l'outil — c'est la sécurité non-contrôlée + patterns figés sur Copilot.</a:t>
+              <a:t>Shadow Cursor grows from 31 to 100+. Claude Code may roll out without governance. The cost isn't the tool — it's uncontrolled security + patterns locked on Copilot.</a:t>
             </a:r>
           </a:p>
         </p:txBody>
@@ -15695,7 +15695,7 @@
                 </a:solidFill>
                 <a:latin typeface="Inter"/>
               </a:rPr>
-              <a:t>Y a-t-il un champion crédible ? Preuves ?</a:t>
+              <a:t>Is there a credible champion? Evidence?</a:t>
             </a:r>
           </a:p>
         </p:txBody>
@@ -15734,7 +15734,7 @@
                 </a:solidFill>
                 <a:latin typeface="Inter"/>
               </a:rPr>
-              <a:t>À tester : Marcel sait-il pour les 31 ? Un staff IC parmi eux est-il identifiable ? Champion = quelqu'un qui défend le deal quand on n'est pas dans la salle.</a:t>
+              <a:t>To test: does Marcel know about the 31? Is a staff IC among them identifiable? Champion = someone who defends the deal when we're not in the room.</a:t>
             </a:r>
           </a:p>
         </p:txBody>
@@ -15856,7 +15856,7 @@
                 </a:solidFill>
                 <a:latin typeface="Inter"/>
               </a:rPr>
-              <a:t>Comment Cursor est-il uniquement positionné ?</a:t>
+              <a:t>How is Cursor uniquely positioned?</a:t>
             </a:r>
           </a:p>
         </p:txBody>
@@ -15895,7 +15895,7 @@
                 </a:solidFill>
                 <a:latin typeface="Inter"/>
               </a:rPr>
-              <a:t>VS Code fork (drop-in pour 85 % de l'équipe) + model neutrality (vs Claude Code) + large codebase performance (vs Copilot) + Privacy Mode (vs shadow actuel).</a:t>
+              <a:t>VS Code fork (drop-in for 85% of the team) + model neutrality (vs Claude Code) + large codebase performance (vs Copilot) + Privacy Mode (vs current shadow usage).</a:t>
             </a:r>
           </a:p>
         </p:txBody>
@@ -16240,7 +16240,7 @@
                 </a:solidFill>
                 <a:latin typeface="Inter"/>
               </a:rPr>
-              <a:t>ANTICIPER, PUIS SE CRITIQUER</a:t>
+              <a:t>ANTICIPATE, THEN SELF-CRITIQUE</a:t>
             </a:r>
           </a:p>
         </p:txBody>
@@ -16279,7 +16279,7 @@
                 </a:solidFill>
                 <a:latin typeface="Inter"/>
               </a:rPr>
-              <a:t>Risks attendus + qu'est-ce que je changerais.</a:t>
+              <a:t>Expected risks + what I would change.</a:t>
             </a:r>
           </a:p>
         </p:txBody>
@@ -16318,7 +16318,7 @@
                 </a:solidFill>
                 <a:latin typeface="Inter"/>
               </a:rPr>
-              <a:t>Self-aware &gt; overconfident. Nommer les fragilités avant qu'on les pointe.</a:t>
+              <a:t>Self-aware &gt; overconfident. Name the fragilities before they're called out.</a:t>
             </a:r>
           </a:p>
         </p:txBody>
@@ -16445,7 +16445,7 @@
                 </a:solidFill>
                 <a:latin typeface="Inter"/>
               </a:rPr>
-              <a:t>DEAL RISKS ANTICIPÉS</a:t>
+              <a:t>ANTICIPATED DEAL RISKS</a:t>
             </a:r>
           </a:p>
         </p:txBody>
@@ -16484,7 +16484,7 @@
                 </a:solidFill>
                 <a:latin typeface="Inter"/>
               </a:rPr>
-              <a:t>Compétition Claude Code</a:t>
+              <a:t>Claude Code competition</a:t>
             </a:r>
           </a:p>
         </p:txBody>
@@ -16523,7 +16523,7 @@
                 </a:solidFill>
                 <a:latin typeface="Inter"/>
               </a:rPr>
-              <a:t>L'eval peut conclure « assez bon » avant qu'on ait livré le POC.</a:t>
+              <a:t>Eval may conclude 'good enough' before we ship our POC.</a:t>
             </a:r>
           </a:p>
         </p:txBody>
@@ -16562,7 +16562,7 @@
                 </a:solidFill>
                 <a:latin typeface="Inter"/>
               </a:rPr>
-              <a:t>Sécurité bloquante</a:t>
+              <a:t>Security as blocker</a:t>
             </a:r>
           </a:p>
         </p:txBody>
@@ -16601,7 +16601,7 @@
                 </a:solidFill>
                 <a:latin typeface="Inter"/>
               </a:rPr>
-              <a:t>Si AppSec n'est pas adressé J0, le pilote glisse de 3 mois.</a:t>
+              <a:t>If AppSec isn't addressed D0, pilot slips 3 months.</a:t>
             </a:r>
           </a:p>
         </p:txBody>
@@ -16640,7 +16640,7 @@
                 </a:solidFill>
                 <a:latin typeface="Inter"/>
               </a:rPr>
-              <a:t>Politique interne</a:t>
+              <a:t>Internal politics</a:t>
             </a:r>
           </a:p>
         </p:txBody>
@@ -16679,7 +16679,7 @@
                 </a:solidFill>
                 <a:latin typeface="Inter"/>
               </a:rPr>
-              <a:t>Copilot a un sponsor org — switch perçu comme un échec interne.</a:t>
+              <a:t>Copilot has an internal sponsor — switch read as a failure.</a:t>
             </a:r>
           </a:p>
         </p:txBody>
@@ -16718,7 +16718,7 @@
                 </a:solidFill>
                 <a:latin typeface="Inter"/>
               </a:rPr>
-              <a:t>Sprawl outils</a:t>
+              <a:t>Tool sprawl</a:t>
             </a:r>
           </a:p>
         </p:txBody>
@@ -16757,7 +16757,7 @@
                 </a:solidFill>
                 <a:latin typeface="Inter"/>
               </a:rPr>
-              <a:t>Cursor + Copilot + Claude Code en parallèle = personne ne décide.</a:t>
+              <a:t>Cursor + Copilot + Claude Code in parallel = no one decides.</a:t>
             </a:r>
           </a:p>
         </p:txBody>
@@ -16835,7 +16835,7 @@
                 </a:solidFill>
                 <a:latin typeface="Inter"/>
               </a:rPr>
-              <a:t>Vendor risk review + DPA = 60–90 j incompressibles.</a:t>
+              <a:t>Vendor risk review + DPA = 60–90 days, non-compressible.</a:t>
             </a:r>
           </a:p>
         </p:txBody>
@@ -17001,7 +17001,7 @@
                 </a:solidFill>
                 <a:latin typeface="Inter"/>
               </a:rPr>
-              <a:t>Ce qui a marché</a:t>
+              <a:t>What worked</a:t>
             </a:r>
           </a:p>
         </p:txBody>
@@ -17040,7 +17040,7 @@
                 </a:solidFill>
                 <a:latin typeface="Inter"/>
               </a:rPr>
-              <a:t>Ouvrir sur les 31 Pro = preuve de prep.</a:t>
+              <a:t>Opening on the 31 Pro = proof of prep.</a:t>
             </a:r>
           </a:p>
           <a:p>
@@ -17056,7 +17056,7 @@
                 </a:solidFill>
                 <a:latin typeface="Inter"/>
               </a:rPr>
-              <a:t>Laisser Marcel formuler le « why now ».</a:t>
+              <a:t>Letting Marcel articulate 'why now'.</a:t>
             </a:r>
           </a:p>
         </p:txBody>
@@ -17095,7 +17095,7 @@
                 </a:solidFill>
                 <a:latin typeface="Inter"/>
               </a:rPr>
-              <a:t>Ce que je changerais</a:t>
+              <a:t>What I'd change</a:t>
             </a:r>
           </a:p>
         </p:txBody>
@@ -17134,7 +17134,7 @@
                 </a:solidFill>
                 <a:latin typeface="Inter"/>
               </a:rPr>
-              <a:t>Plus de temps sur les use-cases concrets (refactos vs review).</a:t>
+              <a:t>More time on concrete use cases (refactors vs review).</a:t>
             </a:r>
           </a:p>
           <a:p>
@@ -17150,7 +17150,7 @@
                 </a:solidFill>
                 <a:latin typeface="Inter"/>
               </a:rPr>
-              <a:t>Pousser plus tôt sur le budget.</a:t>
+              <a:t>Push earlier on budget.</a:t>
             </a:r>
           </a:p>
         </p:txBody>
@@ -17228,7 +17228,7 @@
                 </a:solidFill>
                 <a:latin typeface="Inter"/>
               </a:rPr>
-              <a:t>Account thesis nourrit les questions ciblées.</a:t>
+              <a:t>Account thesis fuels targeted questions.</a:t>
             </a:r>
           </a:p>
           <a:p>
@@ -17244,7 +17244,7 @@
                 </a:solidFill>
                 <a:latin typeface="Inter"/>
               </a:rPr>
-              <a:t>Faits connus = wedges, pas accessoires.</a:t>
+              <a:t>Known facts = wedges, not accessories.</a:t>
             </a:r>
           </a:p>
         </p:txBody>
@@ -17384,7 +17384,7 @@
                 </a:solidFill>
                 <a:latin typeface="Inter"/>
               </a:rPr>
-              <a:t>PART 2  ·  ANTI-BLANK · PHRASES CLÉS</a:t>
+              <a:t>PART 2  ·  ANTI-BLANK · KEY PHRASES</a:t>
             </a:r>
           </a:p>
         </p:txBody>
@@ -17545,7 +17545,7 @@
                 </a:solidFill>
                 <a:latin typeface="Inter"/>
               </a:rPr>
-              <a:t>QUAND ON PERD LE FIL</a:t>
+              <a:t>WHEN YOU LOSE THE THREAD</a:t>
             </a:r>
           </a:p>
         </p:txBody>
@@ -17584,7 +17584,7 @@
                 </a:solidFill>
                 <a:latin typeface="Inter"/>
               </a:rPr>
-              <a:t>6 phrases à dire mot pour mot.</a:t>
+              <a:t>6 phrases to use word-for-word.</a:t>
             </a:r>
           </a:p>
         </p:txBody>
@@ -17623,7 +17623,7 @@
                 </a:solidFill>
                 <a:latin typeface="Inter"/>
               </a:rPr>
-              <a:t>Reprendre la main sans pitcher. Garder l'executive presence sous pression.</a:t>
+              <a:t>Take the wheel back without pitching. Keep executive presence under pressure.</a:t>
             </a:r>
           </a:p>
         </p:txBody>
@@ -17662,7 +17662,7 @@
                 </a:solidFill>
                 <a:latin typeface="Inter"/>
               </a:rPr>
-              <a:t>SI LE SILENCE DURE</a:t>
+              <a:t>IF SILENCE DRAGS</a:t>
             </a:r>
           </a:p>
         </p:txBody>
@@ -17701,7 +17701,7 @@
                 </a:solidFill>
                 <a:latin typeface="Inter"/>
               </a:rPr>
-              <a:t>« Je préfère vous laisser le temps — c'est votre conversation. »</a:t>
+              <a:t>"I'd rather give you the time — this is your conversation."</a:t>
             </a:r>
           </a:p>
         </p:txBody>
@@ -17740,7 +17740,7 @@
                 </a:solidFill>
                 <a:latin typeface="Inter"/>
               </a:rPr>
-              <a:t>SI ON TAPE SUR CURSOR</a:t>
+              <a:t>IF CURSOR GETS HIT</a:t>
             </a:r>
           </a:p>
         </p:txBody>
@@ -17779,7 +17779,7 @@
                 </a:solidFill>
                 <a:latin typeface="Inter"/>
               </a:rPr>
-              <a:t>« C'est un retour fair — voilà ce qu'on fait bien, voilà où on n'est pas le meilleur. »</a:t>
+              <a:t>"Fair feedback — here's what we do well, here's where we're not the best."</a:t>
             </a:r>
           </a:p>
         </p:txBody>
@@ -17818,7 +17818,7 @@
                 </a:solidFill>
                 <a:latin typeface="Inter"/>
               </a:rPr>
-              <a:t>SI ON DEMANDE UN CHIFFRE QU'ON IGNORE</a:t>
+              <a:t>IF ASKED A NUMBER YOU DON'T KNOW</a:t>
             </a:r>
           </a:p>
         </p:txBody>
@@ -17857,7 +17857,7 @@
                 </a:solidFill>
                 <a:latin typeface="Inter"/>
               </a:rPr>
-              <a:t>« Je ne veux pas inventer — je vous reviens dans la journée avec la vraie réponse. »</a:t>
+              <a:t>"I don't want to make one up — I'll get back to you with the real answer today."</a:t>
             </a:r>
           </a:p>
         </p:txBody>
@@ -17896,7 +17896,7 @@
                 </a:solidFill>
                 <a:latin typeface="Inter"/>
               </a:rPr>
-              <a:t>POUR PRESSURE-TEST</a:t>
+              <a:t>TO PRESSURE-TEST</a:t>
             </a:r>
           </a:p>
         </p:txBody>
@@ -17935,7 +17935,7 @@
                 </a:solidFill>
                 <a:latin typeface="Inter"/>
               </a:rPr>
-              <a:t>« Qu'est-ce qui devrait être vrai pour que ce soit un non ? »</a:t>
+              <a:t>"What would need to be true for this to be a no?"</a:t>
             </a:r>
           </a:p>
         </p:txBody>
@@ -17974,7 +17974,7 @@
                 </a:solidFill>
                 <a:latin typeface="Inter"/>
               </a:rPr>
-              <a:t>POUR PASSER À LA SÉCU</a:t>
+              <a:t>TO PIVOT TO SECURITY</a:t>
             </a:r>
           </a:p>
         </p:txBody>
@@ -18013,7 +18013,7 @@
                 </a:solidFill>
                 <a:latin typeface="Inter"/>
               </a:rPr>
-              <a:t>« Avant qu'on aille plus loin, je veux ouvrir la sécu — c'est là où ça se joue. »</a:t>
+              <a:t>"Before we go further, I want to open security — that's where this gets real."</a:t>
             </a:r>
           </a:p>
         </p:txBody>
@@ -18052,7 +18052,7 @@
                 </a:solidFill>
                 <a:latin typeface="Inter"/>
               </a:rPr>
-              <a:t>POUR CLORE</a:t>
+              <a:t>TO CLOSE</a:t>
             </a:r>
           </a:p>
         </p:txBody>
@@ -18091,7 +18091,7 @@
                 </a:solidFill>
                 <a:latin typeface="Inter"/>
               </a:rPr>
-              <a:t>« Une question avant qu'on bloque le follow-up : qu'est-ce que j'aurais dû demander ? »</a:t>
+              <a:t>"One question before we book the follow-up: what should I have asked?"</a:t>
             </a:r>
           </a:p>
         </p:txBody>
@@ -18392,7 +18392,7 @@
                 </a:solidFill>
                 <a:latin typeface="Inter"/>
               </a:rPr>
-              <a:t>À MASQUER PENDANT L'EXERCICE</a:t>
+              <a:t>HIDE DURING THE EXERCISE</a:t>
             </a:r>
           </a:p>
         </p:txBody>
@@ -18431,7 +18431,7 @@
                 </a:solidFill>
                 <a:latin typeface="Inter"/>
               </a:rPr>
-              <a:t>Ce qui est vraiment évalué.</a:t>
+              <a:t>What is actually being evaluated.</a:t>
             </a:r>
           </a:p>
         </p:txBody>
@@ -18470,7 +18470,7 @@
                 </a:solidFill>
                 <a:latin typeface="Inter"/>
               </a:rPr>
-              <a:t>Six dimensions, explicites dans le prompt. À émettre activement les 60 min.</a:t>
+              <a:t>Six dimensions, explicit in the prompt. To project actively across the full 60 min.</a:t>
             </a:r>
           </a:p>
         </p:txBody>
@@ -18597,7 +18597,7 @@
                 </a:solidFill>
                 <a:latin typeface="Inter"/>
               </a:rPr>
-              <a:t>CE QUI EST ÉVALUÉ (du prompt)</a:t>
+              <a:t>WHAT'S BEING EVALUATED (from prompt)</a:t>
             </a:r>
           </a:p>
         </p:txBody>
@@ -18987,7 +18987,7 @@
                 </a:solidFill>
                 <a:latin typeface="Inter"/>
               </a:rPr>
-              <a:t>Executive presence &amp; clarity</a:t>
+              <a:t>Executive presence &amp; clarity of thought</a:t>
             </a:r>
           </a:p>
         </p:txBody>
@@ -19192,7 +19192,7 @@
                 </a:solidFill>
                 <a:latin typeface="Inter"/>
               </a:rPr>
-              <a:t>SIGNAUX (du doc Cursor)</a:t>
+              <a:t>SIGNALS (from Cursor prep doc)</a:t>
             </a:r>
           </a:p>
         </p:txBody>
@@ -19231,7 +19231,7 @@
                 </a:solidFill>
                 <a:latin typeface="Inter"/>
               </a:rPr>
-              <a:t>FORTS — à émettre</a:t>
+              <a:t>STRONG — to project</a:t>
             </a:r>
           </a:p>
         </p:txBody>
@@ -19465,7 +19465,7 @@
                 </a:solidFill>
                 <a:latin typeface="Inter"/>
               </a:rPr>
-              <a:t>FAIBLES — à éviter</a:t>
+              <a:t>WEAK — to avoid</a:t>
             </a:r>
           </a:p>
         </p:txBody>
@@ -19582,7 +19582,7 @@
                 </a:solidFill>
                 <a:latin typeface="Inter"/>
               </a:rPr>
-              <a:t>○ Overconfident sans grounding</a:t>
+              <a:t>○ Overconfident without grounding</a:t>
             </a:r>
           </a:p>
         </p:txBody>
@@ -19904,7 +19904,7 @@
                 </a:solidFill>
                 <a:latin typeface="Inter"/>
               </a:rPr>
-              <a:t>GTM Iberia + Italie. Top 5 ranked, deep dive sur Santander :</a:t>
+              <a:t>Iberia + Italy GTM. Top 5 ranked, deep dive on Santander:</a:t>
             </a:r>
           </a:p>
           <a:p>
@@ -20099,7 +20099,7 @@
                 </a:solidFill>
                 <a:latin typeface="Inter"/>
               </a:rPr>
-              <a:t>PART 1  ·  CRITÈRES DE RANKING</a:t>
+              <a:t>PART 1  ·  RANKING CRITERIA</a:t>
             </a:r>
           </a:p>
         </p:txBody>
@@ -20260,7 +20260,7 @@
                 </a:solidFill>
                 <a:latin typeface="Inter"/>
               </a:rPr>
-              <a:t>AVANT LE TOP 5</a:t>
+              <a:t>BEFORE THE TOP 5</a:t>
             </a:r>
           </a:p>
         </p:txBody>
@@ -20299,7 +20299,7 @@
                 </a:solidFill>
                 <a:latin typeface="Inter"/>
               </a:rPr>
-              <a:t>Comment je classe un compte ENT Spain &amp; Italy.</a:t>
+              <a:t>How I rank an ENT account in Spain &amp; Italy.</a:t>
             </a:r>
           </a:p>
         </p:txBody>
@@ -20338,7 +20338,7 @@
                 </a:solidFill>
                 <a:latin typeface="Inter"/>
               </a:rPr>
-              <a:t>Cinq lentilles, pondérées. Toute exception = on cherche pourquoi.</a:t>
+              <a:t>Five lenses, weighted. Any exception — I find out why.</a:t>
             </a:r>
           </a:p>
         </p:txBody>
@@ -20455,7 +20455,7 @@
                 </a:solidFill>
                 <a:latin typeface="Inter"/>
               </a:rPr>
-              <a:t>≥ 5 K ingés pour un deal enterprise pertinent. Plus c'est gros, plus le math ROI parle.</a:t>
+              <a:t>≥ 5K engineers for a meaningful enterprise deal. The bigger, the louder ROI math gets.</a:t>
             </a:r>
           </a:p>
         </p:txBody>
@@ -20577,7 +20577,7 @@
                 </a:solidFill>
                 <a:latin typeface="Inter"/>
               </a:rPr>
-              <a:t>02 · AI mandate public</a:t>
+              <a:t>02 · Public AI mandate</a:t>
             </a:r>
           </a:p>
         </p:txBody>
@@ -20616,7 +20616,7 @@
                 </a:solidFill>
                 <a:latin typeface="Inter"/>
               </a:rPr>
-              <a:t>Roadmap IA exécutive annoncée → champion réception facilitée, urgence existante.</a:t>
+              <a:t>Executive-announced AI roadmap → easier champion uptake, urgency already exists.</a:t>
             </a:r>
           </a:p>
         </p:txBody>
@@ -20777,7 +20777,7 @@
                 </a:solidFill>
                 <a:latin typeface="Inter"/>
               </a:rPr>
-              <a:t>Régulés EU (DORA, EU AI Act, ECB) = Privacy Mode = enabler, pas blocker. Notre edge.</a:t>
+              <a:t>EU regulated (DORA, EU AI Act, ECB) = Privacy Mode = enabler, not blocker. Our edge.</a:t>
             </a:r>
           </a:p>
         </p:txBody>
@@ -20899,7 +20899,7 @@
                 </a:solidFill>
                 <a:latin typeface="Inter"/>
               </a:rPr>
-              <a:t>04 · Codebase complexité</a:t>
+              <a:t>04 · Codebase complexity</a:t>
             </a:r>
           </a:p>
         </p:txBody>
@@ -20938,7 +20938,7 @@
                 </a:solidFill>
                 <a:latin typeface="Inter"/>
               </a:rPr>
-              <a:t>Legacy + modern + mono / multi repo = large codebase performance pertinent.</a:t>
+              <a:t>Legacy + modern + mono/multi-repo = large codebase performance becomes pivotal.</a:t>
             </a:r>
           </a:p>
         </p:txBody>
@@ -21099,7 +21099,7 @@
                 </a:solidFill>
                 <a:latin typeface="Inter"/>
               </a:rPr>
-              <a:t>Équipe dev-tools identifiable + path procurement traçable = vélocité de deal.</a:t>
+              <a:t>Identifiable dev-tools team + traceable procurement path = deal velocity.</a:t>
             </a:r>
           </a:p>
         </p:txBody>
@@ -21483,7 +21483,7 @@
                 </a:solidFill>
                 <a:latin typeface="Inter"/>
               </a:rPr>
-              <a:t>Top 5 GTM Spain &amp; Italy.</a:t>
+              <a:t>Top 5 — Spain &amp; Italy GTM.</a:t>
             </a:r>
           </a:p>
         </p:txBody>
@@ -21522,7 +21522,7 @@
                 </a:solidFill>
                 <a:latin typeface="Inter"/>
               </a:rPr>
-              <a:t>Ranking défendable. Santander en #1 → deep-dive sur les 4 slides qui suivent.</a:t>
+              <a:t>Defensible ranking. Santander as #1 → deep-dive on the next 4 slides.</a:t>
             </a:r>
           </a:p>
         </p:txBody>
@@ -21727,7 +21727,7 @@
                 </a:solidFill>
                 <a:latin typeface="Inter"/>
               </a:rPr>
-              <a:t>~15–20 K tech · « One Transformation » sous Dirk Marzluf · régulé multi-juridictions · Openbank = wedge digital-native.</a:t>
+              <a:t>~15–20K tech · 'One Transformation' under Dirk Marzluf · multi-jurisdiction regulated · Openbank = digital-native wedge.</a:t>
             </a:r>
           </a:p>
         </p:txBody>
@@ -21766,7 +21766,7 @@
                 </a:solidFill>
                 <a:latin typeface="Inter"/>
               </a:rPr>
-              <a:t>Plus gros TAM Iberia + champion-ready.</a:t>
+              <a:t>Largest Iberia TAM + champion-ready.</a:t>
             </a:r>
           </a:p>
         </p:txBody>
@@ -21971,7 +21971,7 @@
                 </a:solidFill>
                 <a:latin typeface="Inter"/>
               </a:rPr>
-              <a:t>~10 K tech · ChatGPT Enterprise déjà déployé org-wide · narrative « born digital » sous Carlos Torres.</a:t>
+              <a:t>~10K tech · ChatGPT Enterprise already rolled out org-wide · 'born digital' under Carlos Torres.</a:t>
             </a:r>
           </a:p>
         </p:txBody>
@@ -22010,7 +22010,7 @@
                 </a:solidFill>
                 <a:latin typeface="Inter"/>
               </a:rPr>
-              <a:t>AI-ready buyer, vélocité forte.</a:t>
+              <a:t>AI-ready buyer, strong deal velocity.</a:t>
             </a:r>
           </a:p>
         </p:txBody>
@@ -22215,7 +22215,7 @@
                 </a:solidFill>
                 <a:latin typeface="Inter"/>
               </a:rPr>
-              <a:t>~15 K tech · transition énergétique = urgence · OpenInnovability AI lab · CISO mature.</a:t>
+              <a:t>~15K tech · energy transition = urgency · OpenInnovability AI lab · mature CISO function.</a:t>
             </a:r>
           </a:p>
         </p:txBody>
@@ -22254,7 +22254,7 @@
                 </a:solidFill>
                 <a:latin typeface="Inter"/>
               </a:rPr>
-              <a:t>Plus gros TAM Italie.</a:t>
+              <a:t>Largest Italy TAM.</a:t>
             </a:r>
           </a:p>
         </p:txBody>
@@ -22459,7 +22459,7 @@
                 </a:solidFill>
                 <a:latin typeface="Inter"/>
               </a:rPr>
-              <a:t>~5–7 K tech / 190 K total · Industry 4.0 + e-commerce push · régulé (medical devices).</a:t>
+              <a:t>~5–7K tech / 190K total · Industry 4.0 + e-commerce push · regulated (medical devices).</a:t>
             </a:r>
           </a:p>
         </p:txBody>
@@ -22498,7 +22498,7 @@
                 </a:solidFill>
                 <a:latin typeface="Inter"/>
               </a:rPr>
-              <a:t>Compte FR/IT, leverage industriel.</a:t>
+              <a:t>FR/IT footprint, industrial leverage.</a:t>
             </a:r>
           </a:p>
         </p:txBody>
@@ -22703,7 +22703,7 @@
                 </a:solidFill>
                 <a:latin typeface="Inter"/>
               </a:rPr>
-              <a:t>~2–3 K tech · transformation e-commerce + supply chain sous Marta Álvarez · moins de concurrence.</a:t>
+              <a:t>~2–3K tech · e-commerce + supply chain transformation under Marta Álvarez · less crowded.</a:t>
             </a:r>
           </a:p>
         </p:txBody>
@@ -22742,7 +22742,7 @@
                 </a:solidFill>
                 <a:latin typeface="Inter"/>
               </a:rPr>
-              <a:t>Moins crowded, deal accessible.</a:t>
+              <a:t>Less competitive crowding, accessible.</a:t>
             </a:r>
           </a:p>
         </p:txBody>
@@ -23121,7 +23121,7 @@
                 </a:solidFill>
                 <a:latin typeface="Inter"/>
               </a:rPr>
-              <a:t>4 angles. Tous ont une preuve publique citable (analyst calls, presse Iberia).</a:t>
+              <a:t>4 angles. Every one has a public, citable proof point.</a:t>
             </a:r>
           </a:p>
         </p:txBody>
@@ -23287,7 +23287,7 @@
                 </a:solidFill>
                 <a:latin typeface="Inter"/>
               </a:rPr>
-              <a:t>~15–20 K tech (Santander Global</a:t>
+              <a:t>~15–20K tech (Santander Global</a:t>
             </a:r>
           </a:p>
           <a:p>
@@ -23319,7 +23319,7 @@
                 </a:solidFill>
                 <a:latin typeface="Inter"/>
               </a:rPr>
-              <a:t>Ana Botín mentionne l'IA à chaque</a:t>
+              <a:t>Ana Botín references AI on every</a:t>
             </a:r>
           </a:p>
           <a:p>
@@ -23335,7 +23335,7 @@
                 </a:solidFill>
                 <a:latin typeface="Inter"/>
               </a:rPr>
-              <a:t>results call.</a:t>
+              <a:t>earnings call.</a:t>
             </a:r>
           </a:p>
           <a:p>
@@ -23351,7 +23351,7 @@
                 </a:solidFill>
                 <a:latin typeface="Inter"/>
               </a:rPr>
-              <a:t>Partenariats OpenAI + Google Cloud</a:t>
+              <a:t>OpenAI + Google Cloud partnerships</a:t>
             </a:r>
           </a:p>
           <a:p>
@@ -23367,7 +23367,7 @@
                 </a:solidFill>
                 <a:latin typeface="Inter"/>
               </a:rPr>
-              <a:t>annoncés en 2024.</a:t>
+              <a:t>announced in 2024.</a:t>
             </a:r>
           </a:p>
         </p:txBody>
@@ -23533,7 +23533,7 @@
                 </a:solidFill>
                 <a:latin typeface="Inter"/>
               </a:rPr>
-              <a:t>« One Transformation » T&amp;O lancée</a:t>
+              <a:t>'One Transformation' T&amp;O launched</a:t>
             </a:r>
           </a:p>
           <a:p>
@@ -23549,7 +23549,7 @@
                 </a:solidFill>
                 <a:latin typeface="Inter"/>
               </a:rPr>
-              <a:t>2024 sous Dirk Marzluf.</a:t>
+              <a:t>2024 under Dirk Marzluf.</a:t>
             </a:r>
           </a:p>
           <a:p>
@@ -23565,7 +23565,7 @@
                 </a:solidFill>
                 <a:latin typeface="Inter"/>
               </a:rPr>
-              <a:t>BBVA a déployé ChatGPT Enterprise</a:t>
+              <a:t>BBVA deployed ChatGPT Enterprise</a:t>
             </a:r>
           </a:p>
           <a:p>
@@ -23581,7 +23581,7 @@
                 </a:solidFill>
                 <a:latin typeface="Inter"/>
               </a:rPr>
-              <a:t>org-wide → pression compétitive directe.</a:t>
+              <a:t>org-wide → direct competitive pressure.</a:t>
             </a:r>
           </a:p>
           <a:p>
@@ -23597,7 +23597,7 @@
                 </a:solidFill>
                 <a:latin typeface="Inter"/>
               </a:rPr>
-              <a:t>DORA + EU AI Act = urgence</a:t>
+              <a:t>DORA + EU AI Act = AI governance</a:t>
             </a:r>
           </a:p>
           <a:p>
@@ -23613,7 +23613,7 @@
                 </a:solidFill>
                 <a:latin typeface="Inter"/>
               </a:rPr>
-              <a:t>gouvernance IA.</a:t>
+              <a:t>urgency.</a:t>
             </a:r>
           </a:p>
         </p:txBody>
@@ -23740,7 +23740,7 @@
                 </a:solidFill>
                 <a:latin typeface="Inter"/>
               </a:rPr>
-              <a:t>LEVIERS CURSOR</a:t>
+              <a:t>CURSOR LEVERS</a:t>
             </a:r>
           </a:p>
         </p:txBody>
@@ -23795,7 +23795,7 @@
                 </a:solidFill>
                 <a:latin typeface="Inter"/>
               </a:rPr>
-              <a:t>Governance (Privacy Mode pour</a:t>
+              <a:t>Governance (Privacy Mode for</a:t>
             </a:r>
           </a:p>
           <a:p>
@@ -23827,7 +23827,7 @@
                 </a:solidFill>
                 <a:latin typeface="Inter"/>
               </a:rPr>
-              <a:t>Onboarding (rotations 10+ pays).</a:t>
+              <a:t>Onboarding (rotations across 10+</a:t>
             </a:r>
           </a:p>
           <a:p>
@@ -23843,7 +23843,23 @@
                 </a:solidFill>
                 <a:latin typeface="Inter"/>
               </a:rPr>
-              <a:t>Cost (réduction IT spend / revenue).</a:t>
+              <a:t>countries).</a:t>
+            </a:r>
+          </a:p>
+          <a:p>
+            <a:pPr algn="l">
+              <a:lnSpc>
+                <a:spcPct val="150000"/>
+              </a:lnSpc>
+            </a:pPr>
+            <a:r>
+              <a:rPr sz="1100" b="0" i="0">
+                <a:solidFill>
+                  <a:srgbClr val="F5F5F5"/>
+                </a:solidFill>
+                <a:latin typeface="Inter"/>
+              </a:rPr>
+              <a:t>Cost (lower IT spend / revenue ratio).</a:t>
             </a:r>
           </a:p>
         </p:txBody>
@@ -23970,7 +23986,7 @@
                 </a:solidFill>
                 <a:latin typeface="Inter"/>
               </a:rPr>
-              <a:t>FORCES MARCHÉ</a:t>
+              <a:t>MARKET FORCES</a:t>
             </a:r>
           </a:p>
         </p:txBody>
@@ -24009,7 +24025,7 @@
                 </a:solidFill>
                 <a:latin typeface="Inter"/>
               </a:rPr>
-              <a:t>Talent IA cher en Iberia →</a:t>
+              <a:t>AI talent costly in Iberia →</a:t>
             </a:r>
           </a:p>
           <a:p>
@@ -24025,7 +24041,7 @@
                 </a:solidFill>
                 <a:latin typeface="Inter"/>
               </a:rPr>
-              <a:t>outil = levier hiring &amp; rétention.</a:t>
+              <a:t>tool = hiring &amp; retention lever.</a:t>
             </a:r>
           </a:p>
           <a:p>
@@ -24041,7 +24057,7 @@
                 </a:solidFill>
                 <a:latin typeface="Inter"/>
               </a:rPr>
-              <a:t>Model neutrality = résilience face à</a:t>
+              <a:t>Model neutrality = resilience vs</a:t>
             </a:r>
           </a:p>
           <a:p>
@@ -24057,7 +24073,7 @@
                 </a:solidFill>
                 <a:latin typeface="Inter"/>
               </a:rPr>
-              <a:t>l'écosystème EU souverain.</a:t>
+              <a:t>EU sovereign-AI ecosystem.</a:t>
             </a:r>
           </a:p>
           <a:p>
@@ -24073,7 +24089,7 @@
                 </a:solidFill>
                 <a:latin typeface="Inter"/>
               </a:rPr>
-              <a:t>Claude Code en éval chez les pairs</a:t>
+              <a:t>Claude Code being evaluated at EU</a:t>
             </a:r>
           </a:p>
           <a:p>
@@ -24089,7 +24105,7 @@
                 </a:solidFill>
                 <a:latin typeface="Inter"/>
               </a:rPr>
-              <a:t>Européens (ING, BNP).</a:t>
+              <a:t>peers (ING, BNP).</a:t>
             </a:r>
           </a:p>
         </p:txBody>
@@ -24429,7 +24445,7 @@
                 </a:solidFill>
                 <a:latin typeface="Inter"/>
               </a:rPr>
-              <a:t>Qui je cible, dans quel ordre, et pourquoi.</a:t>
+              <a:t>Who I target, in what order, and why.</a:t>
             </a:r>
           </a:p>
         </p:txBody>
@@ -24468,7 +24484,7 @@
                 </a:solidFill>
                 <a:latin typeface="Inter"/>
               </a:rPr>
-              <a:t>Power signals : budget T&amp;O, hiring T&amp;O Madrid/London, sponsorship d'initiatives IA Botín-niveau.</a:t>
+              <a:t>Power signals: T&amp;O budget, T&amp;O hiring in Madrid/London, sponsorship of board-level AI initiatives.</a:t>
             </a:r>
           </a:p>
         </p:txBody>
@@ -24585,7 +24601,7 @@
                 </a:solidFill>
                 <a:latin typeface="Inter"/>
               </a:rPr>
-              <a:t>Wedge #1. Filiale digital-native, autonome, procurement plus court.</a:t>
+              <a:t>Wedge #1. Digital-native subsidiary, autonomous, shorter procurement.</a:t>
             </a:r>
           </a:p>
         </p:txBody>
@@ -24624,7 +24640,7 @@
                 </a:solidFill>
                 <a:latin typeface="Inter"/>
               </a:rPr>
-              <a:t>Cold + LinkedIn. Message : « pilote 30 j sur 1 squad, métriques pré-définies ».</a:t>
+              <a:t>Cold + LinkedIn. Message: '30-day pilot on one squad, metrics pre-defined.'</a:t>
             </a:r>
           </a:p>
         </p:txBody>
@@ -24746,7 +24762,7 @@
                 </a:solidFill>
                 <a:latin typeface="Inter"/>
               </a:rPr>
-              <a:t>Dir / VP Developer Productivity — Santander T&amp;O</a:t>
+              <a:t>VP / Director of Developer Productivity — Santander T&amp;O</a:t>
             </a:r>
           </a:p>
         </p:txBody>
@@ -24785,7 +24801,7 @@
                 </a:solidFill>
                 <a:latin typeface="Inter"/>
               </a:rPr>
-              <a:t>Buyer économique au niveau Groupe. Porte le budget dev tools.</a:t>
+              <a:t>Economic buyer at Group level. Owns the dev tools budget.</a:t>
             </a:r>
           </a:p>
         </p:txBody>
@@ -24824,7 +24840,7 @@
                 </a:solidFill>
                 <a:latin typeface="Inter"/>
               </a:rPr>
-              <a:t>Warm intro Madrid tech community + ref customer EU bank si dispo.</a:t>
+              <a:t>Warm intro via Madrid tech community + EU bank reference customer.</a:t>
             </a:r>
           </a:p>
         </p:txBody>
@@ -24946,7 +24962,7 @@
                 </a:solidFill>
                 <a:latin typeface="Inter"/>
               </a:rPr>
-              <a:t>AppSec leadership (sous le CISO Groupe)</a:t>
+              <a:t>AppSec leadership (under the Group CISO)</a:t>
             </a:r>
           </a:p>
         </p:txBody>
@@ -24985,7 +25001,7 @@
                 </a:solidFill>
                 <a:latin typeface="Inter"/>
               </a:rPr>
-              <a:t>Gatekeeper. Pas un blocker si Privacy Mode + SOC 2 + DORA-aligned anticipés.</a:t>
+              <a:t>Gatekeeper. Not a blocker if Privacy Mode + SOC 2 + DORA-aligned anticipated.</a:t>
             </a:r>
           </a:p>
         </p:txBody>
@@ -25024,7 +25040,7 @@
                 </a:solidFill>
                 <a:latin typeface="Inter"/>
               </a:rPr>
-              <a:t>On les inclut tôt, on envoie SIG + pentest + DPA avant de demander.</a:t>
+              <a:t>Include them early, send SIG + pentest + DPA before asking.</a:t>
             </a:r>
           </a:p>
         </p:txBody>
@@ -25185,7 +25201,7 @@
                 </a:solidFill>
                 <a:latin typeface="Inter"/>
               </a:rPr>
-              <a:t>Exec sponsor. Pas en first touch — on l'engage quand on a un POC chiffré.</a:t>
+              <a:t>Executive sponsor. Not first-touch — engaged once we have a quantified POC.</a:t>
             </a:r>
           </a:p>
         </p:txBody>
@@ -25224,7 +25240,7 @@
                 </a:solidFill>
                 <a:latin typeface="Inter"/>
               </a:rPr>
-              <a:t>Une fois POC live : board-level ROI + risk reduction story.</a:t>
+              <a:t>Once POC live: board-level ROI + risk reduction narrative.</a:t>
             </a:r>
           </a:p>
         </p:txBody>
@@ -25385,7 +25401,7 @@
                 </a:solidFill>
                 <a:latin typeface="Inter"/>
               </a:rPr>
-              <a:t>Adoption shadow = signal Marcel-style. Free tier monitoring sur emails Santander.</a:t>
+              <a:t>Shadow adoption = Marcel-style signal. Free-tier monitoring on @santander.com.</a:t>
             </a:r>
           </a:p>
         </p:txBody>
@@ -25424,7 +25440,7 @@
                 </a:solidFill>
                 <a:latin typeface="Inter"/>
               </a:rPr>
-              <a:t>On surveille signups, on identifie un staff IC champion à Madrid.</a:t>
+              <a:t>Track signups, identify a staff IC champion in Madrid.</a:t>
             </a:r>
           </a:p>
         </p:txBody>
@@ -25808,7 +25824,7 @@
                 </a:solidFill>
                 <a:latin typeface="Inter"/>
               </a:rPr>
-              <a:t>Comment je crée le momentum.</a:t>
+              <a:t>How I create momentum.</a:t>
             </a:r>
           </a:p>
         </p:txBody>
@@ -25847,7 +25863,7 @@
                 </a:solidFill>
                 <a:latin typeface="Inter"/>
               </a:rPr>
-              <a:t>Outreach multi-canal, séquencé, mesurable. 90 jours pour un POC Openbank chiffré.</a:t>
+              <a:t>Multi-channel, sequenced, measurable outreach. 90 days to a quantified Openbank POC.</a:t>
             </a:r>
           </a:p>
         </p:txBody>
@@ -25974,7 +25990,7 @@
                 </a:solidFill>
                 <a:latin typeface="Inter"/>
               </a:rPr>
-              <a:t>ENTRY POINTS — séquencés</a:t>
+              <a:t>ENTRY POINTS — sequenced</a:t>
             </a:r>
           </a:p>
         </p:txBody>
@@ -26052,7 +26068,7 @@
                 </a:solidFill>
                 <a:latin typeface="Inter"/>
               </a:rPr>
-              <a:t>Wedge digital-native. Cible Openbank CTO + Head of Eng. Procurement plus court.</a:t>
+              <a:t>Digital-native wedge. Target Openbank CTO + Head of Eng. Shorter procurement.</a:t>
             </a:r>
           </a:p>
         </p:txBody>
@@ -26130,7 +26146,7 @@
                 </a:solidFill>
                 <a:latin typeface="Inter"/>
               </a:rPr>
-              <a:t>Dir DevProd Santander T&amp;O + AppSec, 3 touches/sem, ROI + ref EU bank.</a:t>
+              <a:t>Dir DevProd Santander T&amp;O + AppSec, 3 touches/week, ROI + EU bank reference.</a:t>
             </a:r>
           </a:p>
         </p:txBody>
@@ -26208,7 +26224,7 @@
                 </a:solidFill>
                 <a:latin typeface="Inter"/>
               </a:rPr>
-              <a:t>Madrid tech community (South Summit, Endeavor, Wayra alumni). Petit monde.</a:t>
+              <a:t>Madrid tech community (South Summit, Endeavor, Wayra alumni). Small world.</a:t>
             </a:r>
           </a:p>
         </p:txBody>
@@ -26247,7 +26263,7 @@
                 </a:solidFill>
                 <a:latin typeface="Inter"/>
               </a:rPr>
-              <a:t>Conférence</a:t>
+              <a:t>Conference</a:t>
             </a:r>
           </a:p>
         </p:txBody>
@@ -26364,7 +26380,7 @@
                 </a:solidFill>
                 <a:latin typeface="Inter"/>
               </a:rPr>
-              <a:t>Free tier monitoring sur @santander.com → champion IC à Madrid/Boston.</a:t>
+              <a:t>Free-tier monitoring on @santander.com → IC champion in Madrid/Boston.</a:t>
             </a:r>
           </a:p>
         </p:txBody>
@@ -26530,7 +26546,7 @@
                 </a:solidFill>
                 <a:latin typeface="JetBrains Mono"/>
               </a:rPr>
-              <a:t>J0–J30</a:t>
+              <a:t>D0–D30</a:t>
             </a:r>
           </a:p>
         </p:txBody>
@@ -26585,7 +26601,7 @@
                 </a:solidFill>
                 <a:latin typeface="Inter"/>
               </a:rPr>
-              <a:t>3 cold touches/sem + 1 warm intro Madrid.</a:t>
+              <a:t>3 cold touches/week + 1 warm intro Madrid.</a:t>
             </a:r>
           </a:p>
           <a:p>
@@ -26601,7 +26617,7 @@
                 </a:solidFill>
                 <a:latin typeface="Inter"/>
               </a:rPr>
-              <a:t>Success : 1 mtg Openbank CTO, 1 mtg AppSec.</a:t>
+              <a:t>Success: 1 mtg Openbank CTO, 1 mtg AppSec.</a:t>
             </a:r>
           </a:p>
         </p:txBody>
@@ -26640,7 +26656,7 @@
                 </a:solidFill>
                 <a:latin typeface="JetBrains Mono"/>
               </a:rPr>
-              <a:t>J30–J60</a:t>
+              <a:t>D30–D60</a:t>
             </a:r>
           </a:p>
         </p:txBody>
@@ -26679,7 +26695,7 @@
                 </a:solidFill>
                 <a:latin typeface="Inter"/>
               </a:rPr>
-              <a:t>Discovery Openbank + parallel intro T&amp;O.</a:t>
+              <a:t>Discovery Openbank + parallel T&amp;O intro.</a:t>
             </a:r>
           </a:p>
           <a:p>
@@ -26695,7 +26711,7 @@
                 </a:solidFill>
                 <a:latin typeface="Inter"/>
               </a:rPr>
-              <a:t>Success : POC 20–30 ingés signé sur 1 squad</a:t>
+              <a:t>Success: 20–30-engineer POC signed on</a:t>
             </a:r>
           </a:p>
           <a:p>
@@ -26711,7 +26727,7 @@
                 </a:solidFill>
                 <a:latin typeface="Inter"/>
               </a:rPr>
-              <a:t>Openbank (mobile ou backend).</a:t>
+              <a:t>one Openbank squad (mobile or backend).</a:t>
             </a:r>
           </a:p>
         </p:txBody>
@@ -26750,7 +26766,7 @@
                 </a:solidFill>
                 <a:latin typeface="JetBrains Mono"/>
               </a:rPr>
-              <a:t>J60–J90</a:t>
+              <a:t>D60–D90</a:t>
             </a:r>
           </a:p>
         </p:txBody>
@@ -26789,7 +26805,7 @@
                 </a:solidFill>
                 <a:latin typeface="Inter"/>
               </a:rPr>
-              <a:t>POC live, Privacy Mode mandaté + DORA-aligned.</a:t>
+              <a:t>POC live, Privacy Mode mandated + DORA-aligned.</a:t>
             </a:r>
           </a:p>
           <a:p>
@@ -26805,7 +26821,7 @@
                 </a:solidFill>
                 <a:latin typeface="Inter"/>
               </a:rPr>
-              <a:t>Success : cycle-time + PR + NPS mesurés.</a:t>
+              <a:t>Success: cycle-time + PR + NPS measured.</a:t>
             </a:r>
           </a:p>
           <a:p>
@@ -26821,7 +26837,7 @@
                 </a:solidFill>
                 <a:latin typeface="Inter"/>
               </a:rPr>
-              <a:t>Ouvre conversation Groupe T&amp;O sur 1 K+ seats.</a:t>
+              <a:t>Opens Group T&amp;O conversation on 1K+ seats.</a:t>
             </a:r>
           </a:p>
         </p:txBody>
@@ -27161,7 +27177,7 @@
                 </a:solidFill>
                 <a:latin typeface="Inter"/>
               </a:rPr>
-              <a:t>À quoi ressemble le POC chiffré.</a:t>
+              <a:t>What the quantified POC looks like.</a:t>
             </a:r>
           </a:p>
         </p:txBody>
@@ -27200,7 +27216,7 @@
                 </a:solidFill>
                 <a:latin typeface="Inter"/>
               </a:rPr>
-              <a:t>Openbank = path of least resistance. Success ici ouvre la conversation Groupe T&amp;O sur 1 K+ seats.</a:t>
+              <a:t>Openbank = path of least resistance. Success here opens Group T&amp;O on 1K+ seats.</a:t>
             </a:r>
           </a:p>
         </p:txBody>
@@ -27366,7 +27382,7 @@
                 </a:solidFill>
                 <a:latin typeface="Inter"/>
               </a:rPr>
-              <a:t>20–30 ingés Openbank (digital-native,</a:t>
+              <a:t>20–30 Openbank engineers</a:t>
             </a:r>
           </a:p>
           <a:p>
@@ -27382,7 +27398,7 @@
                 </a:solidFill>
                 <a:latin typeface="Inter"/>
               </a:rPr>
-              <a:t>stack moderne, vélocité élevée).</a:t>
+              <a:t>(digital-native, modern stack,</a:t>
             </a:r>
           </a:p>
           <a:p>
@@ -27398,7 +27414,7 @@
                 </a:solidFill>
                 <a:latin typeface="Inter"/>
               </a:rPr>
-              <a:t>30 jours.</a:t>
+              <a:t>high velocity).</a:t>
             </a:r>
           </a:p>
           <a:p>
@@ -27414,7 +27430,7 @@
                 </a:solidFill>
                 <a:latin typeface="Inter"/>
               </a:rPr>
-              <a:t>1 squad mobile ou backend, 1 repo de</a:t>
+              <a:t>30 days.</a:t>
             </a:r>
           </a:p>
           <a:p>
@@ -27430,7 +27446,23 @@
                 </a:solidFill>
                 <a:latin typeface="Inter"/>
               </a:rPr>
-              <a:t>référence.</a:t>
+              <a:t>1 mobile or backend squad,</a:t>
+            </a:r>
+          </a:p>
+          <a:p>
+            <a:pPr algn="l">
+              <a:lnSpc>
+                <a:spcPct val="150000"/>
+              </a:lnSpc>
+            </a:pPr>
+            <a:r>
+              <a:rPr sz="1100" b="0" i="0">
+                <a:solidFill>
+                  <a:srgbClr val="F5F5F5"/>
+                </a:solidFill>
+                <a:latin typeface="Inter"/>
+              </a:rPr>
+              <a:t>1 reference repo.</a:t>
             </a:r>
           </a:p>
         </p:txBody>
@@ -27557,7 +27589,7 @@
                 </a:solidFill>
                 <a:latin typeface="Inter"/>
               </a:rPr>
-              <a:t>MÉTRIQUES</a:t>
+              <a:t>METRICS</a:t>
             </a:r>
           </a:p>
         </p:txBody>
@@ -27612,7 +27644,7 @@
                 </a:solidFill>
                 <a:latin typeface="Inter"/>
               </a:rPr>
-              <a:t>PR throughput / ingé / semaine</a:t>
+              <a:t>PR throughput / engineer / week</a:t>
             </a:r>
           </a:p>
           <a:p>
@@ -27644,7 +27676,7 @@
                 </a:solidFill>
                 <a:latin typeface="Inter"/>
               </a:rPr>
-              <a:t>NPS engagement à J+15 et J+30.</a:t>
+              <a:t>NPS engagement at D+15 and D+30.</a:t>
             </a:r>
           </a:p>
         </p:txBody>
@@ -27810,7 +27842,7 @@
                 </a:solidFill>
                 <a:latin typeface="Inter"/>
               </a:rPr>
-              <a:t>Privacy Mode obligatoire.</a:t>
+              <a:t>Privacy Mode mandatory.</a:t>
             </a:r>
           </a:p>
           <a:p>
@@ -27826,7 +27858,7 @@
                 </a:solidFill>
                 <a:latin typeface="Inter"/>
               </a:rPr>
-              <a:t>SOC 2 + SIG envoyés J-7.</a:t>
+              <a:t>SOC 2 + SIG sent D-7.</a:t>
             </a:r>
           </a:p>
           <a:p>
@@ -27842,7 +27874,7 @@
                 </a:solidFill>
                 <a:latin typeface="Inter"/>
               </a:rPr>
-              <a:t>DORA-aligned : audit logs, data</a:t>
+              <a:t>DORA-aligned: audit logs, EU data</a:t>
             </a:r>
           </a:p>
           <a:p>
@@ -27858,7 +27890,7 @@
                 </a:solidFill>
                 <a:latin typeface="Inter"/>
               </a:rPr>
-              <a:t>residency EU validés.</a:t>
+              <a:t>residency validated.</a:t>
             </a:r>
           </a:p>
           <a:p>
@@ -27874,7 +27906,7 @@
                 </a:solidFill>
                 <a:latin typeface="Inter"/>
               </a:rPr>
-              <a:t>AppSec Groupe dans la loop dès J0.</a:t>
+              <a:t>Group AppSec in the loop from D0.</a:t>
             </a:r>
           </a:p>
         </p:txBody>
@@ -28040,7 +28072,7 @@
                 </a:solidFill>
                 <a:latin typeface="Inter"/>
               </a:rPr>
-              <a:t>Cycle-time ↓ ≥ 12 %</a:t>
+              <a:t>Cycle-time ↓ ≥ 12%</a:t>
             </a:r>
           </a:p>
           <a:p>
@@ -28072,7 +28104,7 @@
                 </a:solidFill>
                 <a:latin typeface="Inter"/>
               </a:rPr>
-              <a:t>Senior IC adoption ≥ 60 %</a:t>
+              <a:t>Senior IC adoption ≥ 60%</a:t>
             </a:r>
           </a:p>
           <a:p>
@@ -28088,7 +28120,7 @@
                 </a:solidFill>
                 <a:latin typeface="Inter"/>
               </a:rPr>
-              <a:t>→ ouvre Groupe T&amp;O sur Santander</a:t>
+              <a:t>→ opens Group T&amp;O conversation</a:t>
             </a:r>
           </a:p>
           <a:p>
@@ -28104,7 +28136,7 @@
                 </a:solidFill>
                 <a:latin typeface="Inter"/>
               </a:rPr>
-              <a:t>Global Tech : 1 000–5 000 seats.</a:t>
+              <a:t>on Santander Global Tech: 1K–5K seats.</a:t>
             </a:r>
           </a:p>
         </p:txBody>

</xml_diff>